<commit_message>
design: update app icon and logo assets
</commit_message>
<xml_diff>
--- a/image/logo.pptx
+++ b/image/logo.pptx
@@ -121,6 +121,115 @@
     </p:ext>
   </p:extLst>
 </p:presentation>
+</file>
+
+<file path=ppt/revisionInfo.xml><?xml version="1.0" encoding="utf-8"?>
+<p1510:revInfo xmlns:a="http://schemas.openxmlformats.org/drawingml/2006/main" xmlns:r="http://schemas.openxmlformats.org/officeDocument/2006/relationships" xmlns:p1510="http://schemas.microsoft.com/office/powerpoint/2015/10/main">
+  <p1510:revLst>
+    <p1510:client id="{5059AA37-3761-4AD4-9B86-7459DACAC744}" v="4" dt="2026-05-25T07:37:06.006"/>
+  </p1510:revLst>
+</p1510:revInfo>
+</file>
+
+<file path=ppt/changesInfos/changesInfo1.xml><?xml version="1.0" encoding="utf-8"?>
+<pc:chgInfo xmlns:a="http://schemas.openxmlformats.org/drawingml/2006/main" xmlns:r="http://schemas.openxmlformats.org/officeDocument/2006/relationships" xmlns:ac="http://schemas.microsoft.com/office/drawing/2013/main/command" xmlns:pc="http://schemas.microsoft.com/office/powerpoint/2013/main/command">
+  <pc:docChgLst>
+    <pc:chgData name="Heeyoung Lee" userId="a80b35e00fd5a943" providerId="LiveId" clId="{8800769F-9AC5-45C6-AC73-F753BC2752F5}"/>
+    <pc:docChg chg="undo custSel modSld">
+      <pc:chgData name="Heeyoung Lee" userId="a80b35e00fd5a943" providerId="LiveId" clId="{8800769F-9AC5-45C6-AC73-F753BC2752F5}" dt="2026-05-25T07:37:06.006" v="78" actId="164"/>
+      <pc:docMkLst>
+        <pc:docMk/>
+      </pc:docMkLst>
+      <pc:sldChg chg="addSp delSp modSp mod">
+        <pc:chgData name="Heeyoung Lee" userId="a80b35e00fd5a943" providerId="LiveId" clId="{8800769F-9AC5-45C6-AC73-F753BC2752F5}" dt="2026-05-25T07:37:06.006" v="78" actId="164"/>
+        <pc:sldMkLst>
+          <pc:docMk/>
+          <pc:sldMk cId="263509778" sldId="257"/>
+        </pc:sldMkLst>
+        <pc:spChg chg="mod topLvl">
+          <ac:chgData name="Heeyoung Lee" userId="a80b35e00fd5a943" providerId="LiveId" clId="{8800769F-9AC5-45C6-AC73-F753BC2752F5}" dt="2026-05-25T07:37:06.006" v="78" actId="164"/>
+          <ac:spMkLst>
+            <pc:docMk/>
+            <pc:sldMk cId="263509778" sldId="257"/>
+            <ac:spMk id="5" creationId="{F086C471-C3A4-87BC-BC40-E97B2B52D3BF}"/>
+          </ac:spMkLst>
+        </pc:spChg>
+        <pc:spChg chg="mod topLvl">
+          <ac:chgData name="Heeyoung Lee" userId="a80b35e00fd5a943" providerId="LiveId" clId="{8800769F-9AC5-45C6-AC73-F753BC2752F5}" dt="2026-05-25T07:37:06.006" v="78" actId="164"/>
+          <ac:spMkLst>
+            <pc:docMk/>
+            <pc:sldMk cId="263509778" sldId="257"/>
+            <ac:spMk id="6" creationId="{DBB1B5D0-9D0A-F844-5FAA-636E91FB6D12}"/>
+          </ac:spMkLst>
+        </pc:spChg>
+        <pc:spChg chg="mod topLvl">
+          <ac:chgData name="Heeyoung Lee" userId="a80b35e00fd5a943" providerId="LiveId" clId="{8800769F-9AC5-45C6-AC73-F753BC2752F5}" dt="2026-05-25T07:37:06.006" v="78" actId="164"/>
+          <ac:spMkLst>
+            <pc:docMk/>
+            <pc:sldMk cId="263509778" sldId="257"/>
+            <ac:spMk id="7" creationId="{CB074315-B1C8-DF92-1DCA-44FB58398AAA}"/>
+          </ac:spMkLst>
+        </pc:spChg>
+        <pc:spChg chg="add del mod ord topLvl">
+          <ac:chgData name="Heeyoung Lee" userId="a80b35e00fd5a943" providerId="LiveId" clId="{8800769F-9AC5-45C6-AC73-F753BC2752F5}" dt="2026-05-25T07:37:06.006" v="78" actId="164"/>
+          <ac:spMkLst>
+            <pc:docMk/>
+            <pc:sldMk cId="263509778" sldId="257"/>
+            <ac:spMk id="8" creationId="{3E3B0AE7-39ED-6E71-CCB9-BC3B0182FE3E}"/>
+          </ac:spMkLst>
+        </pc:spChg>
+        <pc:grpChg chg="add del mod">
+          <ac:chgData name="Heeyoung Lee" userId="a80b35e00fd5a943" providerId="LiveId" clId="{8800769F-9AC5-45C6-AC73-F753BC2752F5}" dt="2026-05-25T07:37:03.393" v="77" actId="165"/>
+          <ac:grpSpMkLst>
+            <pc:docMk/>
+            <pc:sldMk cId="263509778" sldId="257"/>
+            <ac:grpSpMk id="18" creationId="{A8FCFE4A-4E45-34A6-674E-E71B85ECD853}"/>
+          </ac:grpSpMkLst>
+        </pc:grpChg>
+        <pc:grpChg chg="add mod">
+          <ac:chgData name="Heeyoung Lee" userId="a80b35e00fd5a943" providerId="LiveId" clId="{8800769F-9AC5-45C6-AC73-F753BC2752F5}" dt="2026-05-25T07:37:06.006" v="78" actId="164"/>
+          <ac:grpSpMkLst>
+            <pc:docMk/>
+            <pc:sldMk cId="263509778" sldId="257"/>
+            <ac:grpSpMk id="19" creationId="{398FE0EB-8880-81A6-432B-50890D1A6C35}"/>
+          </ac:grpSpMkLst>
+        </pc:grpChg>
+        <pc:grpChg chg="del">
+          <ac:chgData name="Heeyoung Lee" userId="a80b35e00fd5a943" providerId="LiveId" clId="{8800769F-9AC5-45C6-AC73-F753BC2752F5}" dt="2026-05-25T07:31:36.303" v="14" actId="165"/>
+          <ac:grpSpMkLst>
+            <pc:docMk/>
+            <pc:sldMk cId="263509778" sldId="257"/>
+            <ac:grpSpMk id="30" creationId="{51C45556-5687-1008-565C-3F584C7AB662}"/>
+          </ac:grpSpMkLst>
+        </pc:grpChg>
+        <pc:cxnChg chg="mod topLvl">
+          <ac:chgData name="Heeyoung Lee" userId="a80b35e00fd5a943" providerId="LiveId" clId="{8800769F-9AC5-45C6-AC73-F753BC2752F5}" dt="2026-05-25T07:37:06.006" v="78" actId="164"/>
+          <ac:cxnSpMkLst>
+            <pc:docMk/>
+            <pc:sldMk cId="263509778" sldId="257"/>
+            <ac:cxnSpMk id="10" creationId="{6764566F-B01F-5F2E-4BC0-FADA1A02254D}"/>
+          </ac:cxnSpMkLst>
+        </pc:cxnChg>
+        <pc:cxnChg chg="mod topLvl">
+          <ac:chgData name="Heeyoung Lee" userId="a80b35e00fd5a943" providerId="LiveId" clId="{8800769F-9AC5-45C6-AC73-F753BC2752F5}" dt="2026-05-25T07:37:06.006" v="78" actId="164"/>
+          <ac:cxnSpMkLst>
+            <pc:docMk/>
+            <pc:sldMk cId="263509778" sldId="257"/>
+            <ac:cxnSpMk id="11" creationId="{14EFFBB8-9244-8A69-6C44-B746E59AE59E}"/>
+          </ac:cxnSpMkLst>
+        </pc:cxnChg>
+        <pc:cxnChg chg="mod topLvl">
+          <ac:chgData name="Heeyoung Lee" userId="a80b35e00fd5a943" providerId="LiveId" clId="{8800769F-9AC5-45C6-AC73-F753BC2752F5}" dt="2026-05-25T07:37:06.006" v="78" actId="164"/>
+          <ac:cxnSpMkLst>
+            <pc:docMk/>
+            <pc:sldMk cId="263509778" sldId="257"/>
+            <ac:cxnSpMk id="15" creationId="{7092BDFC-C72C-1FF9-0DF1-03483DD3BD4C}"/>
+          </ac:cxnSpMkLst>
+        </pc:cxnChg>
+      </pc:sldChg>
+    </pc:docChg>
+  </pc:docChgLst>
+</pc:chgInfo>
 </file>
 
 <file path=ppt/slideLayouts/slideLayout1.xml><?xml version="1.0" encoding="utf-8"?>
@@ -3345,10 +3454,10 @@
       </p:grpSpPr>
       <p:grpSp>
         <p:nvGrpSpPr>
-          <p:cNvPr id="30" name="Group 29">
-            <a:extLst>
-              <a:ext uri="{FF2B5EF4-FFF2-40B4-BE49-F238E27FC236}">
-                <a16:creationId xmlns:a16="http://schemas.microsoft.com/office/drawing/2014/main" id="{51C45556-5687-1008-565C-3F584C7AB662}"/>
+          <p:cNvPr id="19" name="Group 18">
+            <a:extLst>
+              <a:ext uri="{FF2B5EF4-FFF2-40B4-BE49-F238E27FC236}">
+                <a16:creationId xmlns:a16="http://schemas.microsoft.com/office/drawing/2014/main" id="{398FE0EB-8880-81A6-432B-50890D1A6C35}"/>
               </a:ext>
             </a:extLst>
           </p:cNvPr>
@@ -3357,10 +3466,10 @@
         </p:nvGrpSpPr>
         <p:grpSpPr>
           <a:xfrm>
-            <a:off x="3337560" y="402336"/>
-            <a:ext cx="5385816" cy="5321808"/>
-            <a:chOff x="2926080" y="1106424"/>
-            <a:chExt cx="3712464" cy="3767328"/>
+            <a:off x="3695039" y="756298"/>
+            <a:ext cx="5028337" cy="4837466"/>
+            <a:chOff x="3695039" y="756298"/>
+            <a:chExt cx="5028337" cy="4837466"/>
           </a:xfrm>
         </p:grpSpPr>
         <p:cxnSp>
@@ -3379,13 +3488,20 @@
           </p:nvCxnSpPr>
           <p:spPr>
             <a:xfrm flipH="1" flipV="1">
-              <a:off x="3307431" y="1465995"/>
-              <a:ext cx="1432835" cy="2329043"/>
+              <a:off x="4174514" y="1264236"/>
+              <a:ext cx="2327214" cy="3240007"/>
             </a:xfrm>
             <a:prstGeom prst="line">
               <a:avLst/>
             </a:prstGeom>
-            <a:ln w="57150"/>
+            <a:ln w="57150">
+              <a:solidFill>
+                <a:schemeClr val="tx1">
+                  <a:lumMod val="65000"/>
+                  <a:lumOff val="35000"/>
+                </a:schemeClr>
+              </a:solidFill>
+            </a:ln>
           </p:spPr>
           <p:style>
             <a:lnRef idx="3">
@@ -3418,13 +3534,20 @@
           </p:nvCxnSpPr>
           <p:spPr>
             <a:xfrm flipH="1">
-              <a:off x="4759333" y="2630517"/>
-              <a:ext cx="1548707" cy="1153184"/>
+              <a:off x="6501728" y="2555302"/>
+              <a:ext cx="1742173" cy="1948941"/>
             </a:xfrm>
             <a:prstGeom prst="line">
               <a:avLst/>
             </a:prstGeom>
-            <a:ln w="57150"/>
+            <a:ln w="57150">
+              <a:solidFill>
+                <a:schemeClr val="tx1">
+                  <a:lumMod val="65000"/>
+                  <a:lumOff val="35000"/>
+                </a:schemeClr>
+              </a:solidFill>
+            </a:ln>
           </p:spPr>
           <p:style>
             <a:lnRef idx="3">
@@ -3457,13 +3580,20 @@
           </p:nvCxnSpPr>
           <p:spPr>
             <a:xfrm flipH="1">
-              <a:off x="3172492" y="3783701"/>
-              <a:ext cx="1586842" cy="797394"/>
+              <a:off x="4395989" y="4504243"/>
+              <a:ext cx="2105739" cy="581582"/>
             </a:xfrm>
             <a:prstGeom prst="line">
               <a:avLst/>
             </a:prstGeom>
-            <a:ln w="57150"/>
+            <a:ln w="57150">
+              <a:solidFill>
+                <a:schemeClr val="tx1">
+                  <a:lumMod val="65000"/>
+                  <a:lumOff val="35000"/>
+                </a:schemeClr>
+              </a:solidFill>
+            </a:ln>
           </p:spPr>
           <p:style>
             <a:lnRef idx="3">
@@ -3482,6 +3612,58 @@
         </p:cxnSp>
         <p:sp>
           <p:nvSpPr>
+            <p:cNvPr id="8" name="Oval 7">
+              <a:extLst>
+                <a:ext uri="{FF2B5EF4-FFF2-40B4-BE49-F238E27FC236}">
+                  <a16:creationId xmlns:a16="http://schemas.microsoft.com/office/drawing/2014/main" id="{3E3B0AE7-39ED-6E71-CCB9-BC3B0182FE3E}"/>
+                </a:ext>
+              </a:extLst>
+            </p:cNvPr>
+            <p:cNvSpPr/>
+            <p:nvPr/>
+          </p:nvSpPr>
+          <p:spPr>
+            <a:xfrm>
+              <a:off x="5866273" y="3843585"/>
+              <a:ext cx="1336405" cy="1321316"/>
+            </a:xfrm>
+            <a:prstGeom prst="ellipse">
+              <a:avLst/>
+            </a:prstGeom>
+            <a:solidFill>
+              <a:srgbClr val="A40808"/>
+            </a:solidFill>
+            <a:ln>
+              <a:noFill/>
+            </a:ln>
+          </p:spPr>
+          <p:style>
+            <a:lnRef idx="2">
+              <a:schemeClr val="dk1">
+                <a:shade val="15000"/>
+              </a:schemeClr>
+            </a:lnRef>
+            <a:fillRef idx="1">
+              <a:schemeClr val="dk1"/>
+            </a:fillRef>
+            <a:effectRef idx="0">
+              <a:schemeClr val="dk1"/>
+            </a:effectRef>
+            <a:fontRef idx="minor">
+              <a:schemeClr val="lt1"/>
+            </a:fontRef>
+          </p:style>
+          <p:txBody>
+            <a:bodyPr rtlCol="0" anchor="ctr"/>
+            <a:lstStyle/>
+            <a:p>
+              <a:pPr algn="ctr"/>
+              <a:endParaRPr lang="en-US" b="1" dirty="0"/>
+            </a:p>
+          </p:txBody>
+        </p:sp>
+        <p:sp>
+          <p:nvSpPr>
             <p:cNvPr id="7" name="Oval 6">
               <a:extLst>
                 <a:ext uri="{FF2B5EF4-FFF2-40B4-BE49-F238E27FC236}">
@@ -3494,8 +3676,8 @@
           </p:nvSpPr>
           <p:spPr>
             <a:xfrm>
-              <a:off x="2926080" y="4154609"/>
-              <a:ext cx="661008" cy="719143"/>
+              <a:off x="3916514" y="4577887"/>
+              <a:ext cx="958950" cy="1015877"/>
             </a:xfrm>
             <a:prstGeom prst="ellipse">
               <a:avLst/>
@@ -3505,10 +3687,7 @@
             </a:solidFill>
             <a:ln>
               <a:solidFill>
-                <a:schemeClr val="tx1">
-                  <a:lumMod val="95000"/>
-                  <a:lumOff val="5000"/>
-                </a:schemeClr>
+                <a:srgbClr val="A59AB8"/>
               </a:solidFill>
             </a:ln>
           </p:spPr>
@@ -3551,8 +3730,8 @@
           </p:nvSpPr>
           <p:spPr>
             <a:xfrm>
-              <a:off x="5977536" y="2270945"/>
-              <a:ext cx="661008" cy="719143"/>
+              <a:off x="7764426" y="2047363"/>
+              <a:ext cx="958950" cy="1015877"/>
             </a:xfrm>
             <a:prstGeom prst="ellipse">
               <a:avLst/>
@@ -3562,10 +3741,7 @@
             </a:solidFill>
             <a:ln>
               <a:solidFill>
-                <a:schemeClr val="tx1">
-                  <a:lumMod val="95000"/>
-                  <a:lumOff val="5000"/>
-                </a:schemeClr>
+                <a:srgbClr val="A59AB8"/>
               </a:solidFill>
             </a:ln>
           </p:spPr>
@@ -3608,8 +3784,8 @@
           </p:nvSpPr>
           <p:spPr>
             <a:xfrm>
-              <a:off x="2976927" y="1106424"/>
-              <a:ext cx="661008" cy="719143"/>
+              <a:off x="3695039" y="756298"/>
+              <a:ext cx="958950" cy="1015877"/>
             </a:xfrm>
             <a:prstGeom prst="ellipse">
               <a:avLst/>
@@ -3619,67 +3795,7 @@
             </a:solidFill>
             <a:ln>
               <a:solidFill>
-                <a:schemeClr val="tx1">
-                  <a:lumMod val="95000"/>
-                  <a:lumOff val="5000"/>
-                </a:schemeClr>
-              </a:solidFill>
-            </a:ln>
-          </p:spPr>
-          <p:style>
-            <a:lnRef idx="2">
-              <a:schemeClr val="dk1">
-                <a:shade val="15000"/>
-              </a:schemeClr>
-            </a:lnRef>
-            <a:fillRef idx="1">
-              <a:schemeClr val="dk1"/>
-            </a:fillRef>
-            <a:effectRef idx="0">
-              <a:schemeClr val="dk1"/>
-            </a:effectRef>
-            <a:fontRef idx="minor">
-              <a:schemeClr val="lt1"/>
-            </a:fontRef>
-          </p:style>
-          <p:txBody>
-            <a:bodyPr rtlCol="0" anchor="ctr"/>
-            <a:lstStyle/>
-            <a:p>
-              <a:pPr algn="ctr"/>
-              <a:endParaRPr lang="en-US" dirty="0"/>
-            </a:p>
-          </p:txBody>
-        </p:sp>
-        <p:sp>
-          <p:nvSpPr>
-            <p:cNvPr id="8" name="Oval 7">
-              <a:extLst>
-                <a:ext uri="{FF2B5EF4-FFF2-40B4-BE49-F238E27FC236}">
-                  <a16:creationId xmlns:a16="http://schemas.microsoft.com/office/drawing/2014/main" id="{3E3B0AE7-39ED-6E71-CCB9-BC3B0182FE3E}"/>
-                </a:ext>
-              </a:extLst>
-            </p:cNvPr>
-            <p:cNvSpPr/>
-            <p:nvPr/>
-          </p:nvSpPr>
-          <p:spPr>
-            <a:xfrm>
-              <a:off x="4274288" y="3297495"/>
-              <a:ext cx="921189" cy="935365"/>
-            </a:xfrm>
-            <a:prstGeom prst="ellipse">
-              <a:avLst/>
-            </a:prstGeom>
-            <a:solidFill>
-              <a:srgbClr val="A40808"/>
-            </a:solidFill>
-            <a:ln>
-              <a:solidFill>
-                <a:schemeClr val="tx1">
-                  <a:lumMod val="95000"/>
-                  <a:lumOff val="5000"/>
-                </a:schemeClr>
+                <a:srgbClr val="A59AB8"/>
               </a:solidFill>
             </a:ln>
           </p:spPr>

</xml_diff>

<commit_message>
fix: resolve macOS permission error and configure app icon for release
</commit_message>
<xml_diff>
--- a/image/logo.pptx
+++ b/image/logo.pptx
@@ -137,7 +137,7 @@
   <pc:docChgLst>
     <pc:chgData name="Heeyoung Lee" userId="a80b35e00fd5a943" providerId="LiveId" clId="{8800769F-9AC5-45C6-AC73-F753BC2752F5}"/>
     <pc:docChg chg="undo custSel addSld modSld">
-      <pc:chgData name="Heeyoung Lee" userId="a80b35e00fd5a943" providerId="LiveId" clId="{8800769F-9AC5-45C6-AC73-F753BC2752F5}" dt="2026-05-25T11:30:42.178" v="111" actId="164"/>
+      <pc:chgData name="Heeyoung Lee" userId="a80b35e00fd5a943" providerId="LiveId" clId="{8800769F-9AC5-45C6-AC73-F753BC2752F5}" dt="2026-05-25T12:29:05.371" v="127" actId="404"/>
       <pc:docMkLst>
         <pc:docMk/>
       </pc:docMkLst>
@@ -229,13 +229,13 @@
         </pc:cxnChg>
       </pc:sldChg>
       <pc:sldChg chg="addSp modSp add mod">
-        <pc:chgData name="Heeyoung Lee" userId="a80b35e00fd5a943" providerId="LiveId" clId="{8800769F-9AC5-45C6-AC73-F753BC2752F5}" dt="2026-05-25T11:30:42.178" v="111" actId="164"/>
+        <pc:chgData name="Heeyoung Lee" userId="a80b35e00fd5a943" providerId="LiveId" clId="{8800769F-9AC5-45C6-AC73-F753BC2752F5}" dt="2026-05-25T12:29:05.371" v="127" actId="404"/>
         <pc:sldMkLst>
           <pc:docMk/>
           <pc:sldMk cId="2369409367" sldId="258"/>
         </pc:sldMkLst>
         <pc:spChg chg="add mod">
-          <ac:chgData name="Heeyoung Lee" userId="a80b35e00fd5a943" providerId="LiveId" clId="{8800769F-9AC5-45C6-AC73-F753BC2752F5}" dt="2026-05-25T11:30:42.178" v="111" actId="164"/>
+          <ac:chgData name="Heeyoung Lee" userId="a80b35e00fd5a943" providerId="LiveId" clId="{8800769F-9AC5-45C6-AC73-F753BC2752F5}" dt="2026-05-25T12:29:05.371" v="127" actId="404"/>
           <ac:spMkLst>
             <pc:docMk/>
             <pc:sldMk cId="2369409367" sldId="258"/>
@@ -3907,10 +3907,10 @@
         </p:nvGrpSpPr>
         <p:grpSpPr>
           <a:xfrm>
-            <a:off x="3695039" y="756298"/>
-            <a:ext cx="5121059" cy="4837466"/>
-            <a:chOff x="3695039" y="756298"/>
-            <a:chExt cx="5121059" cy="4837466"/>
+            <a:off x="3695039" y="696341"/>
+            <a:ext cx="5386135" cy="4897423"/>
+            <a:chOff x="3695039" y="696341"/>
+            <a:chExt cx="5386135" cy="4897423"/>
           </a:xfrm>
         </p:grpSpPr>
         <p:grpSp>
@@ -4300,8 +4300,8 @@
           </p:nvSpPr>
           <p:spPr>
             <a:xfrm>
-              <a:off x="6712754" y="756298"/>
-              <a:ext cx="2103344" cy="400110"/>
+              <a:off x="6217919" y="696341"/>
+              <a:ext cx="2863255" cy="523220"/>
             </a:xfrm>
             <a:prstGeom prst="rect">
               <a:avLst/>
@@ -4315,7 +4315,7 @@
             <a:lstStyle/>
             <a:p>
               <a:r>
-                <a:rPr lang="en-US" sz="2000" b="1" dirty="0">
+                <a:rPr lang="en-US" sz="2800" b="1" dirty="0">
                   <a:latin typeface="Quire Sans" panose="020B0502040204020203" pitchFamily="34" charset="0"/>
                   <a:cs typeface="Quire Sans" panose="020B0502040204020203" pitchFamily="34" charset="0"/>
                 </a:rPr>

</xml_diff>

<commit_message>
feat: apply new app icon and implement smooth scrolling with custom modern scrollbars
</commit_message>
<xml_diff>
--- a/image/logo.pptx
+++ b/image/logo.pptx
@@ -127,7 +127,7 @@
 <file path=ppt/revisionInfo.xml><?xml version="1.0" encoding="utf-8"?>
 <p1510:revInfo xmlns:a="http://schemas.openxmlformats.org/drawingml/2006/main" xmlns:r="http://schemas.openxmlformats.org/officeDocument/2006/relationships" xmlns:p1510="http://schemas.microsoft.com/office/powerpoint/2015/10/main">
   <p1510:revLst>
-    <p1510:client id="{5059AA37-3761-4AD4-9B86-7459DACAC744}" v="7" dt="2026-05-25T11:30:42.179"/>
+    <p1510:client id="{5059AA37-3761-4AD4-9B86-7459DACAC744}" v="8" dt="2026-05-26T00:38:05.971"/>
   </p1510:revLst>
 </p1510:revInfo>
 </file>
@@ -137,16 +137,24 @@
   <pc:docChgLst>
     <pc:chgData name="Heeyoung Lee" userId="a80b35e00fd5a943" providerId="LiveId" clId="{8800769F-9AC5-45C6-AC73-F753BC2752F5}"/>
     <pc:docChg chg="undo custSel addSld modSld">
-      <pc:chgData name="Heeyoung Lee" userId="a80b35e00fd5a943" providerId="LiveId" clId="{8800769F-9AC5-45C6-AC73-F753BC2752F5}" dt="2026-05-25T12:29:05.371" v="127" actId="404"/>
+      <pc:chgData name="Heeyoung Lee" userId="a80b35e00fd5a943" providerId="LiveId" clId="{8800769F-9AC5-45C6-AC73-F753BC2752F5}" dt="2026-05-26T00:38:05.971" v="141" actId="164"/>
       <pc:docMkLst>
         <pc:docMk/>
       </pc:docMkLst>
       <pc:sldChg chg="addSp delSp modSp mod">
-        <pc:chgData name="Heeyoung Lee" userId="a80b35e00fd5a943" providerId="LiveId" clId="{8800769F-9AC5-45C6-AC73-F753BC2752F5}" dt="2026-05-25T07:37:06.006" v="78" actId="164"/>
+        <pc:chgData name="Heeyoung Lee" userId="a80b35e00fd5a943" providerId="LiveId" clId="{8800769F-9AC5-45C6-AC73-F753BC2752F5}" dt="2026-05-26T00:38:05.971" v="141" actId="164"/>
         <pc:sldMkLst>
           <pc:docMk/>
           <pc:sldMk cId="263509778" sldId="257"/>
         </pc:sldMkLst>
+        <pc:spChg chg="add mod ord">
+          <ac:chgData name="Heeyoung Lee" userId="a80b35e00fd5a943" providerId="LiveId" clId="{8800769F-9AC5-45C6-AC73-F753BC2752F5}" dt="2026-05-26T00:38:05.971" v="141" actId="164"/>
+          <ac:spMkLst>
+            <pc:docMk/>
+            <pc:sldMk cId="263509778" sldId="257"/>
+            <ac:spMk id="2" creationId="{5D626480-CF18-557B-2BD1-291C19FFC39F}"/>
+          </ac:spMkLst>
+        </pc:spChg>
         <pc:spChg chg="mod topLvl">
           <ac:chgData name="Heeyoung Lee" userId="a80b35e00fd5a943" providerId="LiveId" clId="{8800769F-9AC5-45C6-AC73-F753BC2752F5}" dt="2026-05-25T07:37:06.006" v="78" actId="164"/>
           <ac:spMkLst>
@@ -179,6 +187,14 @@
             <ac:spMk id="8" creationId="{3E3B0AE7-39ED-6E71-CCB9-BC3B0182FE3E}"/>
           </ac:spMkLst>
         </pc:spChg>
+        <pc:grpChg chg="add mod">
+          <ac:chgData name="Heeyoung Lee" userId="a80b35e00fd5a943" providerId="LiveId" clId="{8800769F-9AC5-45C6-AC73-F753BC2752F5}" dt="2026-05-26T00:38:05.971" v="141" actId="164"/>
+          <ac:grpSpMkLst>
+            <pc:docMk/>
+            <pc:sldMk cId="263509778" sldId="257"/>
+            <ac:grpSpMk id="3" creationId="{B3574F0C-9C9C-4BA9-984B-51DA462275E0}"/>
+          </ac:grpSpMkLst>
+        </pc:grpChg>
         <pc:grpChg chg="add del mod">
           <ac:chgData name="Heeyoung Lee" userId="a80b35e00fd5a943" providerId="LiveId" clId="{8800769F-9AC5-45C6-AC73-F753BC2752F5}" dt="2026-05-25T07:37:03.393" v="77" actId="165"/>
           <ac:grpSpMkLst>
@@ -188,7 +204,7 @@
           </ac:grpSpMkLst>
         </pc:grpChg>
         <pc:grpChg chg="add mod">
-          <ac:chgData name="Heeyoung Lee" userId="a80b35e00fd5a943" providerId="LiveId" clId="{8800769F-9AC5-45C6-AC73-F753BC2752F5}" dt="2026-05-25T07:37:06.006" v="78" actId="164"/>
+          <ac:chgData name="Heeyoung Lee" userId="a80b35e00fd5a943" providerId="LiveId" clId="{8800769F-9AC5-45C6-AC73-F753BC2752F5}" dt="2026-05-26T00:38:05.971" v="141" actId="164"/>
           <ac:grpSpMkLst>
             <pc:docMk/>
             <pc:sldMk cId="263509778" sldId="257"/>
@@ -411,7 +427,7 @@
           <a:p>
             <a:fld id="{8E33F8BC-07F3-4149-AA7C-285A2A1E88E1}" type="datetimeFigureOut">
               <a:rPr lang="en-US" smtClean="0"/>
-              <a:t>5/25/2026</a:t>
+              <a:t>5/26/2026</a:t>
             </a:fld>
             <a:endParaRPr lang="en-US"/>
           </a:p>
@@ -609,7 +625,7 @@
           <a:p>
             <a:fld id="{8E33F8BC-07F3-4149-AA7C-285A2A1E88E1}" type="datetimeFigureOut">
               <a:rPr lang="en-US" smtClean="0"/>
-              <a:t>5/25/2026</a:t>
+              <a:t>5/26/2026</a:t>
             </a:fld>
             <a:endParaRPr lang="en-US"/>
           </a:p>
@@ -817,7 +833,7 @@
           <a:p>
             <a:fld id="{8E33F8BC-07F3-4149-AA7C-285A2A1E88E1}" type="datetimeFigureOut">
               <a:rPr lang="en-US" smtClean="0"/>
-              <a:t>5/25/2026</a:t>
+              <a:t>5/26/2026</a:t>
             </a:fld>
             <a:endParaRPr lang="en-US"/>
           </a:p>
@@ -1015,7 +1031,7 @@
           <a:p>
             <a:fld id="{8E33F8BC-07F3-4149-AA7C-285A2A1E88E1}" type="datetimeFigureOut">
               <a:rPr lang="en-US" smtClean="0"/>
-              <a:t>5/25/2026</a:t>
+              <a:t>5/26/2026</a:t>
             </a:fld>
             <a:endParaRPr lang="en-US"/>
           </a:p>
@@ -1290,7 +1306,7 @@
           <a:p>
             <a:fld id="{8E33F8BC-07F3-4149-AA7C-285A2A1E88E1}" type="datetimeFigureOut">
               <a:rPr lang="en-US" smtClean="0"/>
-              <a:t>5/25/2026</a:t>
+              <a:t>5/26/2026</a:t>
             </a:fld>
             <a:endParaRPr lang="en-US"/>
           </a:p>
@@ -1555,7 +1571,7 @@
           <a:p>
             <a:fld id="{8E33F8BC-07F3-4149-AA7C-285A2A1E88E1}" type="datetimeFigureOut">
               <a:rPr lang="en-US" smtClean="0"/>
-              <a:t>5/25/2026</a:t>
+              <a:t>5/26/2026</a:t>
             </a:fld>
             <a:endParaRPr lang="en-US"/>
           </a:p>
@@ -1967,7 +1983,7 @@
           <a:p>
             <a:fld id="{8E33F8BC-07F3-4149-AA7C-285A2A1E88E1}" type="datetimeFigureOut">
               <a:rPr lang="en-US" smtClean="0"/>
-              <a:t>5/25/2026</a:t>
+              <a:t>5/26/2026</a:t>
             </a:fld>
             <a:endParaRPr lang="en-US"/>
           </a:p>
@@ -2108,7 +2124,7 @@
           <a:p>
             <a:fld id="{8E33F8BC-07F3-4149-AA7C-285A2A1E88E1}" type="datetimeFigureOut">
               <a:rPr lang="en-US" smtClean="0"/>
-              <a:t>5/25/2026</a:t>
+              <a:t>5/26/2026</a:t>
             </a:fld>
             <a:endParaRPr lang="en-US"/>
           </a:p>
@@ -2221,7 +2237,7 @@
           <a:p>
             <a:fld id="{8E33F8BC-07F3-4149-AA7C-285A2A1E88E1}" type="datetimeFigureOut">
               <a:rPr lang="en-US" smtClean="0"/>
-              <a:t>5/25/2026</a:t>
+              <a:t>5/26/2026</a:t>
             </a:fld>
             <a:endParaRPr lang="en-US"/>
           </a:p>
@@ -2532,7 +2548,7 @@
           <a:p>
             <a:fld id="{8E33F8BC-07F3-4149-AA7C-285A2A1E88E1}" type="datetimeFigureOut">
               <a:rPr lang="en-US" smtClean="0"/>
-              <a:t>5/25/2026</a:t>
+              <a:t>5/26/2026</a:t>
             </a:fld>
             <a:endParaRPr lang="en-US"/>
           </a:p>
@@ -2820,7 +2836,7 @@
           <a:p>
             <a:fld id="{8E33F8BC-07F3-4149-AA7C-285A2A1E88E1}" type="datetimeFigureOut">
               <a:rPr lang="en-US" smtClean="0"/>
-              <a:t>5/25/2026</a:t>
+              <a:t>5/26/2026</a:t>
             </a:fld>
             <a:endParaRPr lang="en-US"/>
           </a:p>
@@ -3061,7 +3077,7 @@
           <a:p>
             <a:fld id="{8E33F8BC-07F3-4149-AA7C-285A2A1E88E1}" type="datetimeFigureOut">
               <a:rPr lang="en-US" smtClean="0"/>
-              <a:t>5/25/2026</a:t>
+              <a:t>5/26/2026</a:t>
             </a:fld>
             <a:endParaRPr lang="en-US"/>
           </a:p>
@@ -3486,10 +3502,10 @@
       </p:grpSpPr>
       <p:grpSp>
         <p:nvGrpSpPr>
-          <p:cNvPr id="19" name="Group 18">
-            <a:extLst>
-              <a:ext uri="{FF2B5EF4-FFF2-40B4-BE49-F238E27FC236}">
-                <a16:creationId xmlns:a16="http://schemas.microsoft.com/office/drawing/2014/main" id="{398FE0EB-8880-81A6-432B-50890D1A6C35}"/>
+          <p:cNvPr id="3" name="Group 2">
+            <a:extLst>
+              <a:ext uri="{FF2B5EF4-FFF2-40B4-BE49-F238E27FC236}">
+                <a16:creationId xmlns:a16="http://schemas.microsoft.com/office/drawing/2014/main" id="{B3574F0C-9C9C-4BA9-984B-51DA462275E0}"/>
               </a:ext>
             </a:extLst>
           </p:cNvPr>
@@ -3498,156 +3514,18 @@
         </p:nvGrpSpPr>
         <p:grpSpPr>
           <a:xfrm>
-            <a:off x="3695039" y="756298"/>
-            <a:ext cx="5028337" cy="4837466"/>
-            <a:chOff x="3695039" y="756298"/>
-            <a:chExt cx="5028337" cy="4837466"/>
+            <a:off x="3364992" y="685800"/>
+            <a:ext cx="5440680" cy="5458968"/>
+            <a:chOff x="3364992" y="685800"/>
+            <a:chExt cx="5440680" cy="5458968"/>
           </a:xfrm>
         </p:grpSpPr>
-        <p:cxnSp>
-          <p:nvCxnSpPr>
-            <p:cNvPr id="10" name="Straight Connector 9">
+        <p:sp>
+          <p:nvSpPr>
+            <p:cNvPr id="2" name="Rectangle: Rounded Corners 1">
               <a:extLst>
                 <a:ext uri="{FF2B5EF4-FFF2-40B4-BE49-F238E27FC236}">
-                  <a16:creationId xmlns:a16="http://schemas.microsoft.com/office/drawing/2014/main" id="{6764566F-B01F-5F2E-4BC0-FADA1A02254D}"/>
-                </a:ext>
-              </a:extLst>
-            </p:cNvPr>
-            <p:cNvCxnSpPr>
-              <a:cxnSpLocks/>
-            </p:cNvCxnSpPr>
-            <p:nvPr/>
-          </p:nvCxnSpPr>
-          <p:spPr>
-            <a:xfrm flipH="1" flipV="1">
-              <a:off x="4174514" y="1264236"/>
-              <a:ext cx="2327214" cy="3240007"/>
-            </a:xfrm>
-            <a:prstGeom prst="line">
-              <a:avLst/>
-            </a:prstGeom>
-            <a:ln w="57150">
-              <a:solidFill>
-                <a:schemeClr val="tx1">
-                  <a:lumMod val="65000"/>
-                  <a:lumOff val="35000"/>
-                </a:schemeClr>
-              </a:solidFill>
-            </a:ln>
-          </p:spPr>
-          <p:style>
-            <a:lnRef idx="3">
-              <a:schemeClr val="dk1"/>
-            </a:lnRef>
-            <a:fillRef idx="0">
-              <a:schemeClr val="dk1"/>
-            </a:fillRef>
-            <a:effectRef idx="2">
-              <a:schemeClr val="dk1"/>
-            </a:effectRef>
-            <a:fontRef idx="minor">
-              <a:schemeClr val="tx1"/>
-            </a:fontRef>
-          </p:style>
-        </p:cxnSp>
-        <p:cxnSp>
-          <p:nvCxnSpPr>
-            <p:cNvPr id="11" name="Straight Connector 10">
-              <a:extLst>
-                <a:ext uri="{FF2B5EF4-FFF2-40B4-BE49-F238E27FC236}">
-                  <a16:creationId xmlns:a16="http://schemas.microsoft.com/office/drawing/2014/main" id="{14EFFBB8-9244-8A69-6C44-B746E59AE59E}"/>
-                </a:ext>
-              </a:extLst>
-            </p:cNvPr>
-            <p:cNvCxnSpPr>
-              <a:cxnSpLocks/>
-            </p:cNvCxnSpPr>
-            <p:nvPr/>
-          </p:nvCxnSpPr>
-          <p:spPr>
-            <a:xfrm flipH="1">
-              <a:off x="6501728" y="2555302"/>
-              <a:ext cx="1742173" cy="1948941"/>
-            </a:xfrm>
-            <a:prstGeom prst="line">
-              <a:avLst/>
-            </a:prstGeom>
-            <a:ln w="57150">
-              <a:solidFill>
-                <a:schemeClr val="tx1">
-                  <a:lumMod val="65000"/>
-                  <a:lumOff val="35000"/>
-                </a:schemeClr>
-              </a:solidFill>
-            </a:ln>
-          </p:spPr>
-          <p:style>
-            <a:lnRef idx="3">
-              <a:schemeClr val="dk1"/>
-            </a:lnRef>
-            <a:fillRef idx="0">
-              <a:schemeClr val="dk1"/>
-            </a:fillRef>
-            <a:effectRef idx="2">
-              <a:schemeClr val="dk1"/>
-            </a:effectRef>
-            <a:fontRef idx="minor">
-              <a:schemeClr val="tx1"/>
-            </a:fontRef>
-          </p:style>
-        </p:cxnSp>
-        <p:cxnSp>
-          <p:nvCxnSpPr>
-            <p:cNvPr id="15" name="Straight Connector 14">
-              <a:extLst>
-                <a:ext uri="{FF2B5EF4-FFF2-40B4-BE49-F238E27FC236}">
-                  <a16:creationId xmlns:a16="http://schemas.microsoft.com/office/drawing/2014/main" id="{7092BDFC-C72C-1FF9-0DF1-03483DD3BD4C}"/>
-                </a:ext>
-              </a:extLst>
-            </p:cNvPr>
-            <p:cNvCxnSpPr>
-              <a:cxnSpLocks/>
-            </p:cNvCxnSpPr>
-            <p:nvPr/>
-          </p:nvCxnSpPr>
-          <p:spPr>
-            <a:xfrm flipH="1">
-              <a:off x="4395989" y="4504243"/>
-              <a:ext cx="2105739" cy="581582"/>
-            </a:xfrm>
-            <a:prstGeom prst="line">
-              <a:avLst/>
-            </a:prstGeom>
-            <a:ln w="57150">
-              <a:solidFill>
-                <a:schemeClr val="tx1">
-                  <a:lumMod val="65000"/>
-                  <a:lumOff val="35000"/>
-                </a:schemeClr>
-              </a:solidFill>
-            </a:ln>
-          </p:spPr>
-          <p:style>
-            <a:lnRef idx="3">
-              <a:schemeClr val="dk1"/>
-            </a:lnRef>
-            <a:fillRef idx="0">
-              <a:schemeClr val="dk1"/>
-            </a:fillRef>
-            <a:effectRef idx="2">
-              <a:schemeClr val="dk1"/>
-            </a:effectRef>
-            <a:fontRef idx="minor">
-              <a:schemeClr val="tx1"/>
-            </a:fontRef>
-          </p:style>
-        </p:cxnSp>
-        <p:sp>
-          <p:nvSpPr>
-            <p:cNvPr id="8" name="Oval 7">
-              <a:extLst>
-                <a:ext uri="{FF2B5EF4-FFF2-40B4-BE49-F238E27FC236}">
-                  <a16:creationId xmlns:a16="http://schemas.microsoft.com/office/drawing/2014/main" id="{3E3B0AE7-39ED-6E71-CCB9-BC3B0182FE3E}"/>
+                  <a16:creationId xmlns:a16="http://schemas.microsoft.com/office/drawing/2014/main" id="{5D626480-CF18-557B-2BD1-291C19FFC39F}"/>
                 </a:ext>
               </a:extLst>
             </p:cNvPr>
@@ -3656,84 +3534,34 @@
           </p:nvSpPr>
           <p:spPr>
             <a:xfrm>
-              <a:off x="5866273" y="3843585"/>
-              <a:ext cx="1336405" cy="1321316"/>
+              <a:off x="3364992" y="685800"/>
+              <a:ext cx="5440680" cy="5458968"/>
             </a:xfrm>
-            <a:prstGeom prst="ellipse">
+            <a:prstGeom prst="roundRect">
               <a:avLst/>
             </a:prstGeom>
             <a:solidFill>
-              <a:srgbClr val="A40808"/>
-            </a:solidFill>
-            <a:ln>
-              <a:noFill/>
-            </a:ln>
-          </p:spPr>
-          <p:style>
-            <a:lnRef idx="2">
-              <a:schemeClr val="dk1">
-                <a:shade val="15000"/>
-              </a:schemeClr>
-            </a:lnRef>
-            <a:fillRef idx="1">
-              <a:schemeClr val="dk1"/>
-            </a:fillRef>
-            <a:effectRef idx="0">
-              <a:schemeClr val="dk1"/>
-            </a:effectRef>
-            <a:fontRef idx="minor">
-              <a:schemeClr val="lt1"/>
-            </a:fontRef>
-          </p:style>
-          <p:txBody>
-            <a:bodyPr rtlCol="0" anchor="ctr"/>
-            <a:lstStyle/>
-            <a:p>
-              <a:pPr algn="ctr"/>
-              <a:endParaRPr lang="en-US" b="1" dirty="0"/>
-            </a:p>
-          </p:txBody>
-        </p:sp>
-        <p:sp>
-          <p:nvSpPr>
-            <p:cNvPr id="7" name="Oval 6">
-              <a:extLst>
-                <a:ext uri="{FF2B5EF4-FFF2-40B4-BE49-F238E27FC236}">
-                  <a16:creationId xmlns:a16="http://schemas.microsoft.com/office/drawing/2014/main" id="{CB074315-B1C8-DF92-1DCA-44FB58398AAA}"/>
-                </a:ext>
-              </a:extLst>
-            </p:cNvPr>
-            <p:cNvSpPr/>
-            <p:nvPr/>
-          </p:nvSpPr>
-          <p:spPr>
-            <a:xfrm>
-              <a:off x="3916514" y="4577887"/>
-              <a:ext cx="958950" cy="1015877"/>
-            </a:xfrm>
-            <a:prstGeom prst="ellipse">
-              <a:avLst/>
-            </a:prstGeom>
-            <a:solidFill>
-              <a:srgbClr val="615478"/>
+              <a:schemeClr val="bg1"/>
             </a:solidFill>
             <a:ln>
               <a:solidFill>
-                <a:srgbClr val="A59AB8"/>
+                <a:schemeClr val="bg2">
+                  <a:lumMod val="25000"/>
+                </a:schemeClr>
               </a:solidFill>
             </a:ln>
           </p:spPr>
           <p:style>
             <a:lnRef idx="2">
-              <a:schemeClr val="dk1">
+              <a:schemeClr val="accent1">
                 <a:shade val="15000"/>
               </a:schemeClr>
             </a:lnRef>
             <a:fillRef idx="1">
-              <a:schemeClr val="dk1"/>
+              <a:schemeClr val="accent1"/>
             </a:fillRef>
             <a:effectRef idx="0">
-              <a:schemeClr val="dk1"/>
+              <a:schemeClr val="accent1"/>
             </a:effectRef>
             <a:fontRef idx="minor">
               <a:schemeClr val="lt1"/>
@@ -3748,114 +3576,379 @@
             </a:p>
           </p:txBody>
         </p:sp>
-        <p:sp>
-          <p:nvSpPr>
-            <p:cNvPr id="6" name="Oval 5">
+        <p:grpSp>
+          <p:nvGrpSpPr>
+            <p:cNvPr id="19" name="Group 18">
               <a:extLst>
                 <a:ext uri="{FF2B5EF4-FFF2-40B4-BE49-F238E27FC236}">
-                  <a16:creationId xmlns:a16="http://schemas.microsoft.com/office/drawing/2014/main" id="{DBB1B5D0-9D0A-F844-5FAA-636E91FB6D12}"/>
+                  <a16:creationId xmlns:a16="http://schemas.microsoft.com/office/drawing/2014/main" id="{398FE0EB-8880-81A6-432B-50890D1A6C35}"/>
                 </a:ext>
               </a:extLst>
             </p:cNvPr>
-            <p:cNvSpPr/>
+            <p:cNvGrpSpPr/>
             <p:nvPr/>
-          </p:nvSpPr>
-          <p:spPr>
+          </p:nvGrpSpPr>
+          <p:grpSpPr>
             <a:xfrm>
-              <a:off x="7764426" y="2047363"/>
-              <a:ext cx="958950" cy="1015877"/>
+              <a:off x="3755567" y="1158929"/>
+              <a:ext cx="4680865" cy="4540141"/>
+              <a:chOff x="3695039" y="756298"/>
+              <a:chExt cx="5028337" cy="4837466"/>
             </a:xfrm>
-            <a:prstGeom prst="ellipse">
-              <a:avLst/>
-            </a:prstGeom>
-            <a:solidFill>
-              <a:srgbClr val="615478"/>
-            </a:solidFill>
-            <a:ln>
+          </p:grpSpPr>
+          <p:cxnSp>
+            <p:nvCxnSpPr>
+              <p:cNvPr id="10" name="Straight Connector 9">
+                <a:extLst>
+                  <a:ext uri="{FF2B5EF4-FFF2-40B4-BE49-F238E27FC236}">
+                    <a16:creationId xmlns:a16="http://schemas.microsoft.com/office/drawing/2014/main" id="{6764566F-B01F-5F2E-4BC0-FADA1A02254D}"/>
+                  </a:ext>
+                </a:extLst>
+              </p:cNvPr>
+              <p:cNvCxnSpPr>
+                <a:cxnSpLocks/>
+              </p:cNvCxnSpPr>
+              <p:nvPr/>
+            </p:nvCxnSpPr>
+            <p:spPr>
+              <a:xfrm flipH="1" flipV="1">
+                <a:off x="4174514" y="1264236"/>
+                <a:ext cx="2327214" cy="3240007"/>
+              </a:xfrm>
+              <a:prstGeom prst="line">
+                <a:avLst/>
+              </a:prstGeom>
+              <a:ln w="57150">
+                <a:solidFill>
+                  <a:schemeClr val="tx1">
+                    <a:lumMod val="65000"/>
+                    <a:lumOff val="35000"/>
+                  </a:schemeClr>
+                </a:solidFill>
+              </a:ln>
+            </p:spPr>
+            <p:style>
+              <a:lnRef idx="3">
+                <a:schemeClr val="dk1"/>
+              </a:lnRef>
+              <a:fillRef idx="0">
+                <a:schemeClr val="dk1"/>
+              </a:fillRef>
+              <a:effectRef idx="2">
+                <a:schemeClr val="dk1"/>
+              </a:effectRef>
+              <a:fontRef idx="minor">
+                <a:schemeClr val="tx1"/>
+              </a:fontRef>
+            </p:style>
+          </p:cxnSp>
+          <p:cxnSp>
+            <p:nvCxnSpPr>
+              <p:cNvPr id="11" name="Straight Connector 10">
+                <a:extLst>
+                  <a:ext uri="{FF2B5EF4-FFF2-40B4-BE49-F238E27FC236}">
+                    <a16:creationId xmlns:a16="http://schemas.microsoft.com/office/drawing/2014/main" id="{14EFFBB8-9244-8A69-6C44-B746E59AE59E}"/>
+                  </a:ext>
+                </a:extLst>
+              </p:cNvPr>
+              <p:cNvCxnSpPr>
+                <a:cxnSpLocks/>
+              </p:cNvCxnSpPr>
+              <p:nvPr/>
+            </p:nvCxnSpPr>
+            <p:spPr>
+              <a:xfrm flipH="1">
+                <a:off x="6501728" y="2555302"/>
+                <a:ext cx="1742173" cy="1948941"/>
+              </a:xfrm>
+              <a:prstGeom prst="line">
+                <a:avLst/>
+              </a:prstGeom>
+              <a:ln w="57150">
+                <a:solidFill>
+                  <a:schemeClr val="tx1">
+                    <a:lumMod val="65000"/>
+                    <a:lumOff val="35000"/>
+                  </a:schemeClr>
+                </a:solidFill>
+              </a:ln>
+            </p:spPr>
+            <p:style>
+              <a:lnRef idx="3">
+                <a:schemeClr val="dk1"/>
+              </a:lnRef>
+              <a:fillRef idx="0">
+                <a:schemeClr val="dk1"/>
+              </a:fillRef>
+              <a:effectRef idx="2">
+                <a:schemeClr val="dk1"/>
+              </a:effectRef>
+              <a:fontRef idx="minor">
+                <a:schemeClr val="tx1"/>
+              </a:fontRef>
+            </p:style>
+          </p:cxnSp>
+          <p:cxnSp>
+            <p:nvCxnSpPr>
+              <p:cNvPr id="15" name="Straight Connector 14">
+                <a:extLst>
+                  <a:ext uri="{FF2B5EF4-FFF2-40B4-BE49-F238E27FC236}">
+                    <a16:creationId xmlns:a16="http://schemas.microsoft.com/office/drawing/2014/main" id="{7092BDFC-C72C-1FF9-0DF1-03483DD3BD4C}"/>
+                  </a:ext>
+                </a:extLst>
+              </p:cNvPr>
+              <p:cNvCxnSpPr>
+                <a:cxnSpLocks/>
+              </p:cNvCxnSpPr>
+              <p:nvPr/>
+            </p:nvCxnSpPr>
+            <p:spPr>
+              <a:xfrm flipH="1">
+                <a:off x="4395989" y="4504243"/>
+                <a:ext cx="2105739" cy="581582"/>
+              </a:xfrm>
+              <a:prstGeom prst="line">
+                <a:avLst/>
+              </a:prstGeom>
+              <a:ln w="57150">
+                <a:solidFill>
+                  <a:schemeClr val="tx1">
+                    <a:lumMod val="65000"/>
+                    <a:lumOff val="35000"/>
+                  </a:schemeClr>
+                </a:solidFill>
+              </a:ln>
+            </p:spPr>
+            <p:style>
+              <a:lnRef idx="3">
+                <a:schemeClr val="dk1"/>
+              </a:lnRef>
+              <a:fillRef idx="0">
+                <a:schemeClr val="dk1"/>
+              </a:fillRef>
+              <a:effectRef idx="2">
+                <a:schemeClr val="dk1"/>
+              </a:effectRef>
+              <a:fontRef idx="minor">
+                <a:schemeClr val="tx1"/>
+              </a:fontRef>
+            </p:style>
+          </p:cxnSp>
+          <p:sp>
+            <p:nvSpPr>
+              <p:cNvPr id="8" name="Oval 7">
+                <a:extLst>
+                  <a:ext uri="{FF2B5EF4-FFF2-40B4-BE49-F238E27FC236}">
+                    <a16:creationId xmlns:a16="http://schemas.microsoft.com/office/drawing/2014/main" id="{3E3B0AE7-39ED-6E71-CCB9-BC3B0182FE3E}"/>
+                  </a:ext>
+                </a:extLst>
+              </p:cNvPr>
+              <p:cNvSpPr/>
+              <p:nvPr/>
+            </p:nvSpPr>
+            <p:spPr>
+              <a:xfrm>
+                <a:off x="5866273" y="3843585"/>
+                <a:ext cx="1336405" cy="1321316"/>
+              </a:xfrm>
+              <a:prstGeom prst="ellipse">
+                <a:avLst/>
+              </a:prstGeom>
               <a:solidFill>
-                <a:srgbClr val="A59AB8"/>
+                <a:srgbClr val="A40808"/>
               </a:solidFill>
-            </a:ln>
-          </p:spPr>
-          <p:style>
-            <a:lnRef idx="2">
-              <a:schemeClr val="dk1">
-                <a:shade val="15000"/>
-              </a:schemeClr>
-            </a:lnRef>
-            <a:fillRef idx="1">
-              <a:schemeClr val="dk1"/>
-            </a:fillRef>
-            <a:effectRef idx="0">
-              <a:schemeClr val="dk1"/>
-            </a:effectRef>
-            <a:fontRef idx="minor">
-              <a:schemeClr val="lt1"/>
-            </a:fontRef>
-          </p:style>
-          <p:txBody>
-            <a:bodyPr rtlCol="0" anchor="ctr"/>
-            <a:lstStyle/>
-            <a:p>
-              <a:pPr algn="ctr"/>
-              <a:endParaRPr lang="en-US" dirty="0"/>
-            </a:p>
-          </p:txBody>
-        </p:sp>
-        <p:sp>
-          <p:nvSpPr>
-            <p:cNvPr id="5" name="Oval 4">
-              <a:extLst>
-                <a:ext uri="{FF2B5EF4-FFF2-40B4-BE49-F238E27FC236}">
-                  <a16:creationId xmlns:a16="http://schemas.microsoft.com/office/drawing/2014/main" id="{F086C471-C3A4-87BC-BC40-E97B2B52D3BF}"/>
-                </a:ext>
-              </a:extLst>
-            </p:cNvPr>
-            <p:cNvSpPr/>
-            <p:nvPr/>
-          </p:nvSpPr>
-          <p:spPr>
-            <a:xfrm>
-              <a:off x="3695039" y="756298"/>
-              <a:ext cx="958950" cy="1015877"/>
-            </a:xfrm>
-            <a:prstGeom prst="ellipse">
-              <a:avLst/>
-            </a:prstGeom>
-            <a:solidFill>
-              <a:srgbClr val="615478"/>
-            </a:solidFill>
-            <a:ln>
+              <a:ln>
+                <a:noFill/>
+              </a:ln>
+            </p:spPr>
+            <p:style>
+              <a:lnRef idx="2">
+                <a:schemeClr val="dk1">
+                  <a:shade val="15000"/>
+                </a:schemeClr>
+              </a:lnRef>
+              <a:fillRef idx="1">
+                <a:schemeClr val="dk1"/>
+              </a:fillRef>
+              <a:effectRef idx="0">
+                <a:schemeClr val="dk1"/>
+              </a:effectRef>
+              <a:fontRef idx="minor">
+                <a:schemeClr val="lt1"/>
+              </a:fontRef>
+            </p:style>
+            <p:txBody>
+              <a:bodyPr rtlCol="0" anchor="ctr"/>
+              <a:lstStyle/>
+              <a:p>
+                <a:pPr algn="ctr"/>
+                <a:endParaRPr lang="en-US" b="1" dirty="0"/>
+              </a:p>
+            </p:txBody>
+          </p:sp>
+          <p:sp>
+            <p:nvSpPr>
+              <p:cNvPr id="7" name="Oval 6">
+                <a:extLst>
+                  <a:ext uri="{FF2B5EF4-FFF2-40B4-BE49-F238E27FC236}">
+                    <a16:creationId xmlns:a16="http://schemas.microsoft.com/office/drawing/2014/main" id="{CB074315-B1C8-DF92-1DCA-44FB58398AAA}"/>
+                  </a:ext>
+                </a:extLst>
+              </p:cNvPr>
+              <p:cNvSpPr/>
+              <p:nvPr/>
+            </p:nvSpPr>
+            <p:spPr>
+              <a:xfrm>
+                <a:off x="3916514" y="4577887"/>
+                <a:ext cx="958950" cy="1015877"/>
+              </a:xfrm>
+              <a:prstGeom prst="ellipse">
+                <a:avLst/>
+              </a:prstGeom>
               <a:solidFill>
-                <a:srgbClr val="A59AB8"/>
+                <a:srgbClr val="615478"/>
               </a:solidFill>
-            </a:ln>
-          </p:spPr>
-          <p:style>
-            <a:lnRef idx="2">
-              <a:schemeClr val="dk1">
-                <a:shade val="15000"/>
-              </a:schemeClr>
-            </a:lnRef>
-            <a:fillRef idx="1">
-              <a:schemeClr val="dk1"/>
-            </a:fillRef>
-            <a:effectRef idx="0">
-              <a:schemeClr val="dk1"/>
-            </a:effectRef>
-            <a:fontRef idx="minor">
-              <a:schemeClr val="lt1"/>
-            </a:fontRef>
-          </p:style>
-          <p:txBody>
-            <a:bodyPr rtlCol="0" anchor="ctr"/>
-            <a:lstStyle/>
-            <a:p>
-              <a:pPr algn="ctr"/>
-              <a:endParaRPr lang="en-US" dirty="0"/>
-            </a:p>
-          </p:txBody>
-        </p:sp>
+              <a:ln>
+                <a:solidFill>
+                  <a:srgbClr val="A59AB8"/>
+                </a:solidFill>
+              </a:ln>
+            </p:spPr>
+            <p:style>
+              <a:lnRef idx="2">
+                <a:schemeClr val="dk1">
+                  <a:shade val="15000"/>
+                </a:schemeClr>
+              </a:lnRef>
+              <a:fillRef idx="1">
+                <a:schemeClr val="dk1"/>
+              </a:fillRef>
+              <a:effectRef idx="0">
+                <a:schemeClr val="dk1"/>
+              </a:effectRef>
+              <a:fontRef idx="minor">
+                <a:schemeClr val="lt1"/>
+              </a:fontRef>
+            </p:style>
+            <p:txBody>
+              <a:bodyPr rtlCol="0" anchor="ctr"/>
+              <a:lstStyle/>
+              <a:p>
+                <a:pPr algn="ctr"/>
+                <a:endParaRPr lang="en-US" dirty="0"/>
+              </a:p>
+            </p:txBody>
+          </p:sp>
+          <p:sp>
+            <p:nvSpPr>
+              <p:cNvPr id="6" name="Oval 5">
+                <a:extLst>
+                  <a:ext uri="{FF2B5EF4-FFF2-40B4-BE49-F238E27FC236}">
+                    <a16:creationId xmlns:a16="http://schemas.microsoft.com/office/drawing/2014/main" id="{DBB1B5D0-9D0A-F844-5FAA-636E91FB6D12}"/>
+                  </a:ext>
+                </a:extLst>
+              </p:cNvPr>
+              <p:cNvSpPr/>
+              <p:nvPr/>
+            </p:nvSpPr>
+            <p:spPr>
+              <a:xfrm>
+                <a:off x="7764426" y="2047363"/>
+                <a:ext cx="958950" cy="1015877"/>
+              </a:xfrm>
+              <a:prstGeom prst="ellipse">
+                <a:avLst/>
+              </a:prstGeom>
+              <a:solidFill>
+                <a:srgbClr val="615478"/>
+              </a:solidFill>
+              <a:ln>
+                <a:solidFill>
+                  <a:srgbClr val="A59AB8"/>
+                </a:solidFill>
+              </a:ln>
+            </p:spPr>
+            <p:style>
+              <a:lnRef idx="2">
+                <a:schemeClr val="dk1">
+                  <a:shade val="15000"/>
+                </a:schemeClr>
+              </a:lnRef>
+              <a:fillRef idx="1">
+                <a:schemeClr val="dk1"/>
+              </a:fillRef>
+              <a:effectRef idx="0">
+                <a:schemeClr val="dk1"/>
+              </a:effectRef>
+              <a:fontRef idx="minor">
+                <a:schemeClr val="lt1"/>
+              </a:fontRef>
+            </p:style>
+            <p:txBody>
+              <a:bodyPr rtlCol="0" anchor="ctr"/>
+              <a:lstStyle/>
+              <a:p>
+                <a:pPr algn="ctr"/>
+                <a:endParaRPr lang="en-US" dirty="0"/>
+              </a:p>
+            </p:txBody>
+          </p:sp>
+          <p:sp>
+            <p:nvSpPr>
+              <p:cNvPr id="5" name="Oval 4">
+                <a:extLst>
+                  <a:ext uri="{FF2B5EF4-FFF2-40B4-BE49-F238E27FC236}">
+                    <a16:creationId xmlns:a16="http://schemas.microsoft.com/office/drawing/2014/main" id="{F086C471-C3A4-87BC-BC40-E97B2B52D3BF}"/>
+                  </a:ext>
+                </a:extLst>
+              </p:cNvPr>
+              <p:cNvSpPr/>
+              <p:nvPr/>
+            </p:nvSpPr>
+            <p:spPr>
+              <a:xfrm>
+                <a:off x="3695039" y="756298"/>
+                <a:ext cx="958950" cy="1015877"/>
+              </a:xfrm>
+              <a:prstGeom prst="ellipse">
+                <a:avLst/>
+              </a:prstGeom>
+              <a:solidFill>
+                <a:srgbClr val="615478"/>
+              </a:solidFill>
+              <a:ln>
+                <a:solidFill>
+                  <a:srgbClr val="A59AB8"/>
+                </a:solidFill>
+              </a:ln>
+            </p:spPr>
+            <p:style>
+              <a:lnRef idx="2">
+                <a:schemeClr val="dk1">
+                  <a:shade val="15000"/>
+                </a:schemeClr>
+              </a:lnRef>
+              <a:fillRef idx="1">
+                <a:schemeClr val="dk1"/>
+              </a:fillRef>
+              <a:effectRef idx="0">
+                <a:schemeClr val="dk1"/>
+              </a:effectRef>
+              <a:fontRef idx="minor">
+                <a:schemeClr val="lt1"/>
+              </a:fontRef>
+            </p:style>
+            <p:txBody>
+              <a:bodyPr rtlCol="0" anchor="ctr"/>
+              <a:lstStyle/>
+              <a:p>
+                <a:pPr algn="ctr"/>
+                <a:endParaRPr lang="en-US" dirty="0"/>
+              </a:p>
+            </p:txBody>
+          </p:sp>
+        </p:grpSp>
       </p:grpSp>
     </p:spTree>
     <p:extLst>

</xml_diff>